<commit_message>
feat(taller): manual PDF + PPTX corregido + email actualizado
Manual técnico PDF (78 páginas, 277 KB):
- Explicación profunda de las 18 herramientas (qué hace, cuándo SÍ/NO, install, uso básico, uso avanzado, integración CI/CD, troubleshooting)
- Todos los scripts en bloques copy-paste (bash/python/yaml/colang/output)
- Generado con weasyprint a partir de HTML+CSS profesional
- Boxes destacados: TIP, WARNING, DANGER, USE CASE
- TOC navegable, paginación, headers/footers

PPTX corregido (46 slides):
- Rediseñado tool_slide() con layout 2 columnas (QR arriba, output abajo)
- Recortadas terminales de 10 herramientas que se desbordaban
- Reducidos bloques de código YAML densos (Promptfoo, CI workflow)
- Eliminados solapamientos texto/footer en slides 6, 10, 16, 25, 27, 36, 39, 41, 42

Email actualizado: jose.bobal@gmail.com -> jmpicon@jmpicon.com en
README, slides Marp, scripts build, kit-asistentes, manual.

Co-Authored-By: Claude Opus 4.7 (1M context) <noreply@anthropic.com>
</commit_message>
<xml_diff>
--- a/taller/SecuAI_Hackeando_la_IA.pptx
+++ b/taller/SecuAI_Hackeando_la_IA.pptx
@@ -7287,7 +7287,7 @@
                 </a:solidFill>
                 <a:latin typeface="Calibri"/>
               </a:rPr>
-              <a:t>José Picón · jose.bobal@gmail.com</a:t>
+              <a:t>José Picón · jmpicon@jmpicon.com</a:t>
             </a:r>
           </a:p>
         </p:txBody>
@@ -43837,7 +43837,7 @@
                 </a:solidFill>
                 <a:latin typeface="Calibri"/>
               </a:rPr>
-              <a:t>jose.bobal@gmail.com</a:t>
+              <a:t>jmpicon@jmpicon.com</a:t>
             </a:r>
           </a:p>
         </p:txBody>
@@ -44657,7 +44657,7 @@
                 </a:solidFill>
                 <a:latin typeface="Calibri"/>
               </a:rPr>
-              <a:t>José Picón  ·  jose.bobal@gmail.com  ·  SecuAI 2026</a:t>
+              <a:t>José Picón  ·  jmpicon@jmpicon.com  ·  SecuAI 2026</a:t>
             </a:r>
           </a:p>
         </p:txBody>

</xml_diff>